<commit_message>
data-eng: 3-2 덱 5개(w3d2s0 신설 · 파일 이름·[us]·9행·3-3·3-4 참조)
</commit_message>
<xml_diff>
--- a/data-eng/decks/w3d2s1.pptx
+++ b/data-eng/decks/w3d2s1.pptx
@@ -3100,7 +3100,7 @@
       <p:grpSpPr/>
       <p:sp>
         <p:nvSpPr>
-          <p:cNvPr id="2" name="Oval 1"/>
+          <p:cNvPr id="2" name="deckgen:decor"/>
           <p:cNvSpPr/>
           <p:nvPr/>
         </p:nvSpPr>
@@ -3130,7 +3130,7 @@
       </p:sp>
       <p:sp>
         <p:nvSpPr>
-          <p:cNvPr id="3" name="Oval 2"/>
+          <p:cNvPr id="3" name="deckgen:decor"/>
           <p:cNvSpPr/>
           <p:nvPr/>
         </p:nvSpPr>
@@ -3160,7 +3160,7 @@
       </p:sp>
       <p:sp>
         <p:nvSpPr>
-          <p:cNvPr id="4" name="Oval 3"/>
+          <p:cNvPr id="4" name="deckgen:decor"/>
           <p:cNvSpPr/>
           <p:nvPr/>
         </p:nvSpPr>
@@ -3190,7 +3190,7 @@
       </p:sp>
       <p:sp>
         <p:nvSpPr>
-          <p:cNvPr id="5" name="Rectangle 4"/>
+          <p:cNvPr id="5" name="deckgen:decor"/>
           <p:cNvSpPr/>
           <p:nvPr/>
         </p:nvSpPr>
@@ -3220,7 +3220,7 @@
       </p:sp>
       <p:sp>
         <p:nvSpPr>
-          <p:cNvPr id="6" name="Oval 5"/>
+          <p:cNvPr id="6" name="deckgen:decor"/>
           <p:cNvSpPr/>
           <p:nvPr/>
         </p:nvSpPr>
@@ -3250,7 +3250,7 @@
       </p:sp>
       <p:sp>
         <p:nvSpPr>
-          <p:cNvPr id="7" name="Oval 6"/>
+          <p:cNvPr id="7" name="deckgen:decor"/>
           <p:cNvSpPr/>
           <p:nvPr/>
         </p:nvSpPr>
@@ -3280,7 +3280,7 @@
       </p:sp>
       <p:sp>
         <p:nvSpPr>
-          <p:cNvPr id="8" name="Oval 7"/>
+          <p:cNvPr id="8" name="deckgen:decor"/>
           <p:cNvSpPr/>
           <p:nvPr/>
         </p:nvSpPr>
@@ -3310,7 +3310,7 @@
       </p:sp>
       <p:sp>
         <p:nvSpPr>
-          <p:cNvPr id="9" name="Oval 8"/>
+          <p:cNvPr id="9" name="deckgen:decor"/>
           <p:cNvSpPr/>
           <p:nvPr/>
         </p:nvSpPr>
@@ -3340,7 +3340,7 @@
       </p:sp>
       <p:sp>
         <p:nvSpPr>
-          <p:cNvPr id="10" name="Rectangle 9"/>
+          <p:cNvPr id="10" name="deckgen:decor"/>
           <p:cNvSpPr/>
           <p:nvPr/>
         </p:nvSpPr>
@@ -3600,7 +3600,7 @@
       <p:grpSpPr/>
       <p:sp>
         <p:nvSpPr>
-          <p:cNvPr id="2" name="Oval 1"/>
+          <p:cNvPr id="2" name="deckgen:decor"/>
           <p:cNvSpPr/>
           <p:nvPr/>
         </p:nvSpPr>
@@ -3630,7 +3630,7 @@
       </p:sp>
       <p:sp>
         <p:nvSpPr>
-          <p:cNvPr id="3" name="Oval 2"/>
+          <p:cNvPr id="3" name="deckgen:decor"/>
           <p:cNvSpPr/>
           <p:nvPr/>
         </p:nvSpPr>
@@ -3660,7 +3660,7 @@
       </p:sp>
       <p:sp>
         <p:nvSpPr>
-          <p:cNvPr id="4" name="Oval 3"/>
+          <p:cNvPr id="4" name="deckgen:decor"/>
           <p:cNvSpPr/>
           <p:nvPr/>
         </p:nvSpPr>
@@ -4808,7 +4808,7 @@
       <p:grpSpPr/>
       <p:sp>
         <p:nvSpPr>
-          <p:cNvPr id="2" name="Oval 1"/>
+          <p:cNvPr id="2" name="deckgen:decor"/>
           <p:cNvSpPr/>
           <p:nvPr/>
         </p:nvSpPr>
@@ -4838,7 +4838,7 @@
       </p:sp>
       <p:sp>
         <p:nvSpPr>
-          <p:cNvPr id="3" name="Oval 2"/>
+          <p:cNvPr id="3" name="deckgen:decor"/>
           <p:cNvSpPr/>
           <p:nvPr/>
         </p:nvSpPr>
@@ -5615,7 +5615,7 @@
       <p:grpSpPr/>
       <p:sp>
         <p:nvSpPr>
-          <p:cNvPr id="2" name="Oval 1"/>
+          <p:cNvPr id="2" name="deckgen:decor"/>
           <p:cNvSpPr/>
           <p:nvPr/>
         </p:nvSpPr>
@@ -5645,7 +5645,7 @@
       </p:sp>
       <p:sp>
         <p:nvSpPr>
-          <p:cNvPr id="3" name="Oval 2"/>
+          <p:cNvPr id="3" name="deckgen:decor"/>
           <p:cNvSpPr/>
           <p:nvPr/>
         </p:nvSpPr>
@@ -5675,7 +5675,7 @@
       </p:sp>
       <p:sp>
         <p:nvSpPr>
-          <p:cNvPr id="4" name="Oval 3"/>
+          <p:cNvPr id="4" name="deckgen:decor"/>
           <p:cNvSpPr/>
           <p:nvPr/>
         </p:nvSpPr>
@@ -6606,7 +6606,7 @@
       <p:grpSpPr/>
       <p:sp>
         <p:nvSpPr>
-          <p:cNvPr id="2" name="Oval 1"/>
+          <p:cNvPr id="2" name="deckgen:decor"/>
           <p:cNvSpPr/>
           <p:nvPr/>
         </p:nvSpPr>
@@ -6636,7 +6636,7 @@
       </p:sp>
       <p:sp>
         <p:nvSpPr>
-          <p:cNvPr id="3" name="Oval 2"/>
+          <p:cNvPr id="3" name="deckgen:decor"/>
           <p:cNvSpPr/>
           <p:nvPr/>
         </p:nvSpPr>
@@ -6666,7 +6666,7 @@
       </p:sp>
       <p:sp>
         <p:nvSpPr>
-          <p:cNvPr id="4" name="Oval 3"/>
+          <p:cNvPr id="4" name="deckgen:decor"/>
           <p:cNvSpPr/>
           <p:nvPr/>
         </p:nvSpPr>
@@ -7469,7 +7469,7 @@
                 <a:ea typeface="Pretendard"/>
                 <a:cs typeface="Pretendard"/>
               </a:rPr>
-              <a:t>2-2 에서 배운 SQL GROUP BY 와 같은 동작 — 도구만 바뀌었으니 그때 잡은 감각 그대로</a:t>
+              <a:t>2-1 에서 배운 SQL GROUP BY 와 같은 동작 — 도구만 바뀌었으니 그때 잡은 감각 그대로</a:t>
             </a:r>
           </a:p>
         </p:txBody>
@@ -7606,7 +7606,7 @@
       <p:grpSpPr/>
       <p:sp>
         <p:nvSpPr>
-          <p:cNvPr id="2" name="Oval 1"/>
+          <p:cNvPr id="2" name="deckgen:decor"/>
           <p:cNvSpPr/>
           <p:nvPr/>
         </p:nvSpPr>
@@ -7636,7 +7636,7 @@
       </p:sp>
       <p:sp>
         <p:nvSpPr>
-          <p:cNvPr id="3" name="Oval 2"/>
+          <p:cNvPr id="3" name="deckgen:decor"/>
           <p:cNvSpPr/>
           <p:nvPr/>
         </p:nvSpPr>
@@ -7666,7 +7666,7 @@
       </p:sp>
       <p:sp>
         <p:nvSpPr>
-          <p:cNvPr id="4" name="Oval 3"/>
+          <p:cNvPr id="4" name="deckgen:decor"/>
           <p:cNvSpPr/>
           <p:nvPr/>
         </p:nvSpPr>
@@ -8667,7 +8667,7 @@
       <p:grpSpPr/>
       <p:sp>
         <p:nvSpPr>
-          <p:cNvPr id="2" name="Oval 1"/>
+          <p:cNvPr id="2" name="deckgen:decor"/>
           <p:cNvSpPr/>
           <p:nvPr/>
         </p:nvSpPr>
@@ -8697,7 +8697,7 @@
       </p:sp>
       <p:sp>
         <p:nvSpPr>
-          <p:cNvPr id="3" name="Oval 2"/>
+          <p:cNvPr id="3" name="deckgen:decor"/>
           <p:cNvSpPr/>
           <p:nvPr/>
         </p:nvSpPr>
@@ -8727,7 +8727,7 @@
       </p:sp>
       <p:sp>
         <p:nvSpPr>
-          <p:cNvPr id="4" name="Oval 3"/>
+          <p:cNvPr id="4" name="deckgen:decor"/>
           <p:cNvSpPr/>
           <p:nvPr/>
         </p:nvSpPr>
@@ -10153,7 +10153,7 @@
       <p:grpSpPr/>
       <p:sp>
         <p:nvSpPr>
-          <p:cNvPr id="2" name="Oval 1"/>
+          <p:cNvPr id="2" name="deckgen:decor"/>
           <p:cNvSpPr/>
           <p:nvPr/>
         </p:nvSpPr>
@@ -10183,7 +10183,7 @@
       </p:sp>
       <p:sp>
         <p:nvSpPr>
-          <p:cNvPr id="3" name="Oval 2"/>
+          <p:cNvPr id="3" name="deckgen:decor"/>
           <p:cNvSpPr/>
           <p:nvPr/>
         </p:nvSpPr>
@@ -10213,7 +10213,7 @@
       </p:sp>
       <p:sp>
         <p:nvSpPr>
-          <p:cNvPr id="4" name="Oval 3"/>
+          <p:cNvPr id="4" name="deckgen:decor"/>
           <p:cNvSpPr/>
           <p:nvPr/>
         </p:nvSpPr>
@@ -11251,7 +11251,7 @@
       <p:grpSpPr/>
       <p:sp>
         <p:nvSpPr>
-          <p:cNvPr id="2" name="Oval 1"/>
+          <p:cNvPr id="2" name="deckgen:decor"/>
           <p:cNvSpPr/>
           <p:nvPr/>
         </p:nvSpPr>
@@ -11281,7 +11281,7 @@
       </p:sp>
       <p:sp>
         <p:nvSpPr>
-          <p:cNvPr id="3" name="Oval 2"/>
+          <p:cNvPr id="3" name="deckgen:decor"/>
           <p:cNvSpPr/>
           <p:nvPr/>
         </p:nvSpPr>
@@ -11311,7 +11311,7 @@
       </p:sp>
       <p:sp>
         <p:nvSpPr>
-          <p:cNvPr id="4" name="Oval 3"/>
+          <p:cNvPr id="4" name="deckgen:decor"/>
           <p:cNvSpPr/>
           <p:nvPr/>
         </p:nvSpPr>
@@ -12516,7 +12516,7 @@
       <p:grpSpPr/>
       <p:sp>
         <p:nvSpPr>
-          <p:cNvPr id="2" name="Oval 1"/>
+          <p:cNvPr id="2" name="deckgen:decor"/>
           <p:cNvSpPr/>
           <p:nvPr/>
         </p:nvSpPr>
@@ -12546,7 +12546,7 @@
       </p:sp>
       <p:sp>
         <p:nvSpPr>
-          <p:cNvPr id="3" name="Oval 2"/>
+          <p:cNvPr id="3" name="deckgen:decor"/>
           <p:cNvSpPr/>
           <p:nvPr/>
         </p:nvSpPr>
@@ -12576,7 +12576,7 @@
       </p:sp>
       <p:sp>
         <p:nvSpPr>
-          <p:cNvPr id="4" name="Oval 3"/>
+          <p:cNvPr id="4" name="deckgen:decor"/>
           <p:cNvSpPr/>
           <p:nvPr/>
         </p:nvSpPr>
@@ -13822,7 +13822,7 @@
       <p:grpSpPr/>
       <p:sp>
         <p:nvSpPr>
-          <p:cNvPr id="2" name="Oval 1"/>
+          <p:cNvPr id="2" name="deckgen:decor"/>
           <p:cNvSpPr/>
           <p:nvPr/>
         </p:nvSpPr>
@@ -13852,7 +13852,7 @@
       </p:sp>
       <p:sp>
         <p:nvSpPr>
-          <p:cNvPr id="3" name="Oval 2"/>
+          <p:cNvPr id="3" name="deckgen:decor"/>
           <p:cNvSpPr/>
           <p:nvPr/>
         </p:nvSpPr>
@@ -13882,7 +13882,7 @@
       </p:sp>
       <p:sp>
         <p:nvSpPr>
-          <p:cNvPr id="4" name="Oval 3"/>
+          <p:cNvPr id="4" name="deckgen:decor"/>
           <p:cNvSpPr/>
           <p:nvPr/>
         </p:nvSpPr>

</xml_diff>